<commit_message>
feat(examples): build No Knead Bread-test.pptx as exact visual mirror of clean deck with paired auto-remediatable barriers
</commit_message>
<xml_diff>
--- a/examples/No Knead Bread-test.pptx
+++ b/examples/No Knead Bread-test.pptx
@@ -111,130 +111,13 @@
   <p:extLst>
     <p:ext uri="{521415D9-36F7-43E2-AB2F-EE9909263876}">
       <p14:sectionLst xmlns:p14="http://schemas.microsoft.com/office/powerpoint/2010/main">
-        <p14:section name="Default Section" id="{default section}"/>
-        <p14:section name="Baking Section" id="{baking section}"/>
-        <p14:section name="Baking Section" id="{baking section}"/>
+        <p14:section name="Default Section" id="{default-sec-0}"/>
+        <p14:section name="Default Section" id="{default-sec-1}"/>
+        <p14:section name="Default Section" id="{default-sec-2}"/>
       </p14:sectionLst>
     </p:ext>
   </p:extLst>
-  <p:modifyVerifier cryptProviderType="rsaAES" hashData="dummy"/>
 </p:presentation>
-</file>
-
-<file path=ppt/charts/chart1.xml><?xml version="1.0" encoding="utf-8"?>
-<c:chartSpace xmlns:c="http://schemas.openxmlformats.org/drawingml/2006/chart" xmlns:a="http://schemas.openxmlformats.org/drawingml/2006/main" xmlns:r="http://schemas.openxmlformats.org/officeDocument/2006/relationships">
-  <c:date1904 val="0"/>
-  <c:chart>
-    <c:autoTitleDeleted val="0"/>
-    <c:plotArea>
-      <c:barChart>
-        <c:barDir val="col"/>
-        <c:grouping val="clustered"/>
-        <c:ser>
-          <c:idx val="0"/>
-          <c:order val="0"/>
-          <c:tx>
-            <c:strRef>
-              <c:f>Sheet1!$B$1</c:f>
-              <c:strCache>
-                <c:ptCount val="1"/>
-                <c:pt idx="0">
-                  <c:v>Grams</c:v>
-                </c:pt>
-              </c:strCache>
-            </c:strRef>
-          </c:tx>
-          <c:cat>
-            <c:strRef>
-              <c:f>Sheet1!$A$2:$A$5</c:f>
-              <c:strCache>
-                <c:ptCount val="4"/>
-                <c:pt idx="0">
-                  <c:v>Flour</c:v>
-                </c:pt>
-                <c:pt idx="1">
-                  <c:v>Water</c:v>
-                </c:pt>
-                <c:pt idx="2">
-                  <c:v>Salt</c:v>
-                </c:pt>
-                <c:pt idx="3">
-                  <c:v>Yeast</c:v>
-                </c:pt>
-              </c:strCache>
-            </c:strRef>
-          </c:cat>
-          <c:val>
-            <c:numRef>
-              <c:f>Sheet1!$B$2:$B$5</c:f>
-              <c:numCache>
-                <c:formatCode>General</c:formatCode>
-                <c:ptCount val="4"/>
-                <c:pt idx="0">
-                  <c:v>400</c:v>
-                </c:pt>
-                <c:pt idx="1">
-                  <c:v>300</c:v>
-                </c:pt>
-                <c:pt idx="2">
-                  <c:v>10</c:v>
-                </c:pt>
-                <c:pt idx="3">
-                  <c:v>3</c:v>
-                </c:pt>
-              </c:numCache>
-            </c:numRef>
-          </c:val>
-        </c:ser>
-        <c:axId val="-2068027336"/>
-        <c:axId val="-2113994440"/>
-      </c:barChart>
-      <c:catAx>
-        <c:axId val="-2068027336"/>
-        <c:scaling>
-          <c:orientation val="minMax"/>
-        </c:scaling>
-        <c:delete val="0"/>
-        <c:axPos val="b"/>
-        <c:majorTickMark val="out"/>
-        <c:minorTickMark val="none"/>
-        <c:tickLblPos val="nextTo"/>
-        <c:crossAx val="-2113994440"/>
-        <c:crosses val="autoZero"/>
-        <c:auto val="1"/>
-        <c:lblAlgn val="ctr"/>
-        <c:lblOffset val="100"/>
-        <c:noMultiLvlLbl val="0"/>
-      </c:catAx>
-      <c:valAx>
-        <c:axId val="-2113994440"/>
-        <c:scaling/>
-        <c:delete val="0"/>
-        <c:axPos val="l"/>
-        <c:majorGridlines/>
-        <c:majorTickMark val="out"/>
-        <c:minorTickMark val="none"/>
-        <c:tickLblPos val="nextTo"/>
-        <c:crossAx val="-2068027336"/>
-        <c:crosses val="autoZero"/>
-      </c:valAx>
-    </c:plotArea>
-    <c:dispBlanksAs val="gap"/>
-  </c:chart>
-  <c:txPr>
-    <a:bodyPr/>
-    <a:lstStyle/>
-    <a:p>
-      <a:pPr>
-        <a:defRPr sz="1800"/>
-      </a:pPr>
-      <a:endParaRPr lang="en-US"/>
-    </a:p>
-  </c:txPr>
-  <c:externalData r:id="rId1">
-    <c:autoUpdate val="0"/>
-  </c:externalData>
-</c:chartSpace>
 </file>
 
 <file path=ppt/slideLayouts/slideLayout1.xml><?xml version="1.0" encoding="utf-8"?>
@@ -3228,17 +3111,19 @@
             <p:ph type="subTitle" idx="1"/>
           </p:nvPr>
         </p:nvSpPr>
-        <p:spPr>
-          <a:xfrm>
-            <a:off x="914400" y="3657600"/>
-          </a:xfrm>
-        </p:spPr>
-        <p:txBody>
-          <a:bodyPr/>
-          <a:lstStyle/>
-          <a:p>
-            <a:r>
-              <a:t>No kneading required, 4 simple ingredients.</a:t>
+        <p:spPr/>
+        <p:txBody>
+          <a:bodyPr/>
+          <a:lstStyle/>
+          <a:p>
+            <a:r>
+              <a:rPr sz="1800" b="0">
+                <a:solidFill>
+                  <a:srgbClr val="475569"/>
+                </a:solidFill>
+                <a:latin typeface="Calibri"/>
+              </a:rPr>
+              <a:t>No kneading required, 4 simple ingredients, baked in a Dutch Oven.</a:t>
             </a:r>
           </a:p>
         </p:txBody>
@@ -3253,16 +3138,18 @@
             <p:ph type="ctrTitle"/>
           </p:nvPr>
         </p:nvSpPr>
-        <p:spPr>
-          <a:xfrm>
-            <a:off x="914400" y="1371600"/>
-          </a:xfrm>
-        </p:spPr>
-        <p:txBody>
-          <a:bodyPr/>
-          <a:lstStyle/>
-          <a:p>
-            <a:r>
+        <p:spPr/>
+        <p:txBody>
+          <a:bodyPr/>
+          <a:lstStyle/>
+          <a:p>
+            <a:r>
+              <a:rPr sz="4000" b="1">
+                <a:solidFill>
+                  <a:srgbClr val="0F172A"/>
+                </a:solidFill>
+                <a:latin typeface="Calibri"/>
+              </a:rPr>
               <a:t>No Knead Bread</a:t>
             </a:r>
           </a:p>
@@ -3300,7 +3187,17 @@
         <p:txBody>
           <a:bodyPr/>
           <a:lstStyle/>
-          <a:p/>
+          <a:p>
+            <a:r>
+              <a:rPr sz="3000" b="1">
+                <a:solidFill>
+                  <a:srgbClr val="0F172A"/>
+                </a:solidFill>
+                <a:latin typeface="Calibri"/>
+              </a:rPr>
+              <a:t>Introduction &amp; Overview</a:t>
+            </a:r>
+          </a:p>
         </p:txBody>
       </p:sp>
       <p:sp>
@@ -3310,51 +3207,126 @@
             <a:spLocks noGrp="1"/>
           </p:cNvSpPr>
           <p:nvPr>
-            <p:ph idx="1"/>
-          </p:nvPr>
-        </p:nvSpPr>
-        <p:spPr/>
-        <p:txBody>
-          <a:bodyPr/>
-          <a:lstStyle/>
-          <a:p>
-            <a:r>
-              <a:rPr lang="en-US"/>
-              <a:t>Overview of the bread baking process and ingredients.</a:t>
-            </a:r>
-          </a:p>
-          <a:p>
-            <a:r>
-              <a:rPr lang="en-US"/>
-              <a:t>For baking tips, </a:t>
-            </a:r>
-            <a:r>
-              <a:rPr lang="en-US">
-                <a:hlinkClick r:id="rId2"/>
+            <p:ph idx="1" sz="half"/>
+          </p:nvPr>
+        </p:nvSpPr>
+        <p:spPr>
+          <a:xfrm>
+            <a:off x="731520" y="1463040"/>
+            <a:ext cx="4114800" cy="4754880"/>
+          </a:xfrm>
+          <a:solidFill>
+            <a:srgbClr val="F8FAFC"/>
+          </a:solidFill>
+          <a:ln w="12700">
+            <a:solidFill>
+              <a:srgbClr val="CBD5E1"/>
+            </a:solidFill>
+          </a:ln>
+        </p:spPr>
+        <p:txBody>
+          <a:bodyPr lIns="256032" rIns="256032" tIns="256032" bIns="256032" wrap="square"/>
+          <a:lstStyle/>
+          <a:p>
+            <a:pPr>
+              <a:spcBef>
+                <a:spcPts val="0"/>
+              </a:spcBef>
+              <a:spcAft>
+                <a:spcPts val="1200"/>
+              </a:spcAft>
+              <a:buNone/>
+            </a:pPr>
+            <a:r>
+              <a:rPr sz="1100" b="1">
+                <a:solidFill>
+                  <a:srgbClr val="0369A1"/>
+                </a:solidFill>
+                <a:latin typeface="Calibri"/>
               </a:rPr>
-              <a:t>click here</a:t>
+              <a:t>OVERVIEW &amp; PHILOSOPHY</a:t>
+            </a:r>
+          </a:p>
+          <a:p>
+            <a:pPr>
+              <a:spcBef>
+                <a:spcPts val="0"/>
+              </a:spcBef>
+              <a:spcAft>
+                <a:spcPts val="1200"/>
+              </a:spcAft>
+              <a:buNone/>
+            </a:pPr>
+            <a:r>
+              <a:rPr sz="1350" b="0">
+                <a:solidFill>
+                  <a:srgbClr val="334155"/>
+                </a:solidFill>
+                <a:latin typeface="Calibri"/>
+              </a:rPr>
+              <a:t>The simplicity of this no-knead bread is what makes it a household favorite. Your entire home will fill with the aroma of fresh artisan bakery bread as it bakes.</a:t>
+            </a:r>
+          </a:p>
+          <a:p>
+            <a:pPr>
+              <a:spcBef>
+                <a:spcPts val="0"/>
+              </a:spcBef>
+              <a:spcAft>
+                <a:spcPts val="1200"/>
+              </a:spcAft>
+              <a:buNone/>
+            </a:pPr>
+            <a:r>
+              <a:rPr sz="1350" b="0">
+                <a:solidFill>
+                  <a:srgbClr val="334155"/>
+                </a:solidFill>
+                <a:latin typeface="Calibri"/>
+              </a:rPr>
+              <a:t>Requiring zero special equipment and just four basic pantry staples, this method delivers a golden, blistered crust and a moist, airy crumb.</a:t>
+            </a:r>
+          </a:p>
+          <a:p>
+            <a:pPr>
+              <a:spcBef>
+                <a:spcPts val="0"/>
+              </a:spcBef>
+              <a:spcAft>
+                <a:spcPts val="0"/>
+              </a:spcAft>
+              <a:buNone/>
+            </a:pPr>
+            <a:r>
+              <a:rPr sz="1350" b="0">
+                <a:solidFill>
+                  <a:srgbClr val="334155"/>
+                </a:solidFill>
+                <a:latin typeface="Calibri"/>
+              </a:rPr>
+              <a:t>A slow, 12 to 18-hour room-temperature fermentation develops rich flavor and a chewy artisan texture without any manual kneading.</a:t>
             </a:r>
           </a:p>
         </p:txBody>
       </p:sp>
       <p:pic>
         <p:nvPicPr>
-          <p:cNvPr id="4" name="Bread Photo"/>
+          <p:cNvPr id="4" name="Artisan Bread Loaf"/>
           <p:cNvPicPr>
             <a:picLocks noChangeAspect="1"/>
           </p:cNvPicPr>
           <p:nvPr/>
         </p:nvPicPr>
         <p:blipFill>
-          <a:blip r:embed="rId3"/>
+          <a:blip r:embed="rId2"/>
           <a:stretch>
             <a:fillRect/>
           </a:stretch>
         </p:blipFill>
         <p:spPr>
           <a:xfrm>
-            <a:off x="5029200" y="2011680"/>
-            <a:ext cx="3474720" cy="2303890"/>
+            <a:off x="5120640" y="1463040"/>
+            <a:ext cx="3383280" cy="2243262"/>
           </a:xfrm>
           <a:prstGeom prst="rect">
             <a:avLst/>
@@ -3395,8 +3367,13 @@
           <a:lstStyle/>
           <a:p>
             <a:r>
-              <a:rPr lang="en-US"/>
-              <a:t>Recipe Details</a:t>
+              <a:rPr sz="3000" b="1">
+                <a:solidFill>
+                  <a:srgbClr val="0F172A"/>
+                </a:solidFill>
+                <a:latin typeface="Calibri"/>
+              </a:rPr>
+              <a:t>Ingredients</a:t>
             </a:r>
           </a:p>
         </p:txBody>
@@ -3410,8 +3387,8 @@
           <p:nvPr/>
         </p:nvGraphicFramePr>
         <p:xfrm>
-          <a:off x="914400" y="1828800"/>
-          <a:ext cx="7315200" cy="2286000"/>
+          <a:off x="914400" y="1645920"/>
+          <a:ext cx="7315200" cy="2926080"/>
         </p:xfrm>
         <a:graphic>
           <a:graphicData uri="http://schemas.openxmlformats.org/drawingml/2006/table">
@@ -3424,87 +3401,344 @@
                 <a:gridCol w="2438400"/>
                 <a:gridCol w="2438400"/>
               </a:tblGrid>
-              <a:tr h="762000">
-                <a:tc gridSpan="2">
+              <a:tr h="585216">
+                <a:tc>
                   <a:txBody>
                     <a:bodyPr/>
                     <a:lstStyle/>
                     <a:p>
                       <a:r>
-                        <a:rPr lang="en-US"/>
-                        <a:t>Merged Ingredients Header</a:t>
+                        <a:rPr lang="en-US" sz="1400" b="1">
+                          <a:solidFill>
+                            <a:srgbClr val="FFFFFF"/>
+                          </a:solidFill>
+                          <a:latin typeface="Calibri"/>
+                        </a:rPr>
+                        <a:t>Ingredient</a:t>
                       </a:r>
                     </a:p>
                   </a:txBody>
-                  <a:tcPr/>
+                  <a:tcPr>
+                    <a:solidFill>
+                      <a:srgbClr val="0F172A"/>
+                    </a:solidFill>
+                  </a:tcPr>
                 </a:tc>
                 <a:tc>
                   <a:txBody>
                     <a:bodyPr/>
                     <a:lstStyle/>
-                    <a:p/>
+                    <a:p>
+                      <a:r>
+                        <a:rPr lang="en-US" sz="1400" b="1">
+                          <a:solidFill>
+                            <a:srgbClr val="FFFFFF"/>
+                          </a:solidFill>
+                          <a:latin typeface="Calibri"/>
+                        </a:rPr>
+                        <a:t>Quantity</a:t>
+                      </a:r>
+                    </a:p>
                   </a:txBody>
-                  <a:tcPr/>
+                  <a:tcPr>
+                    <a:solidFill>
+                      <a:srgbClr val="0F172A"/>
+                    </a:solidFill>
+                  </a:tcPr>
                 </a:tc>
                 <a:tc>
                   <a:txBody>
                     <a:bodyPr/>
                     <a:lstStyle/>
-                    <a:p/>
+                    <a:p>
+                      <a:r>
+                        <a:rPr lang="en-US" sz="1400" b="1">
+                          <a:solidFill>
+                            <a:srgbClr val="FFFFFF"/>
+                          </a:solidFill>
+                          <a:latin typeface="Calibri"/>
+                        </a:rPr>
+                        <a:t>Notes</a:t>
+                      </a:r>
+                    </a:p>
                   </a:txBody>
-                  <a:tcPr/>
+                  <a:tcPr>
+                    <a:solidFill>
+                      <a:srgbClr val="0F172A"/>
+                    </a:solidFill>
+                  </a:tcPr>
                 </a:tc>
               </a:tr>
-              <a:tr h="762000">
+              <a:tr h="585216">
                 <a:tc>
                   <a:txBody>
                     <a:bodyPr/>
                     <a:lstStyle/>
-                    <a:p/>
+                    <a:p>
+                      <a:r>
+                        <a:rPr lang="en-US" sz="1350" b="0">
+                          <a:solidFill>
+                            <a:srgbClr val="334155"/>
+                          </a:solidFill>
+                          <a:latin typeface="Calibri"/>
+                        </a:rPr>
+                        <a:t>All-Purpose Flour</a:t>
+                      </a:r>
+                    </a:p>
                   </a:txBody>
-                  <a:tcPr/>
+                  <a:tcPr>
+                    <a:solidFill>
+                      <a:srgbClr val="F8FAFC"/>
+                    </a:solidFill>
+                  </a:tcPr>
                 </a:tc>
                 <a:tc>
                   <a:txBody>
                     <a:bodyPr/>
                     <a:lstStyle/>
-                    <a:p/>
+                    <a:p>
+                      <a:r>
+                        <a:rPr lang="en-US" sz="1350" b="0">
+                          <a:solidFill>
+                            <a:srgbClr val="334155"/>
+                          </a:solidFill>
+                          <a:latin typeface="Calibri"/>
+                        </a:rPr>
+                        <a:t>3 cups</a:t>
+                      </a:r>
+                    </a:p>
                   </a:txBody>
-                  <a:tcPr/>
+                  <a:tcPr>
+                    <a:solidFill>
+                      <a:srgbClr val="F8FAFC"/>
+                    </a:solidFill>
+                  </a:tcPr>
                 </a:tc>
                 <a:tc>
                   <a:txBody>
                     <a:bodyPr/>
                     <a:lstStyle/>
-                    <a:p/>
+                    <a:p>
+                      <a:r>
+                        <a:rPr lang="en-US" sz="1350" b="0">
+                          <a:solidFill>
+                            <a:srgbClr val="334155"/>
+                          </a:solidFill>
+                          <a:latin typeface="Calibri"/>
+                        </a:rPr>
+                        <a:t>Unbleached white flour preferred</a:t>
+                      </a:r>
+                    </a:p>
                   </a:txBody>
-                  <a:tcPr/>
+                  <a:tcPr>
+                    <a:solidFill>
+                      <a:srgbClr val="F8FAFC"/>
+                    </a:solidFill>
+                  </a:tcPr>
                 </a:tc>
               </a:tr>
-              <a:tr h="762000">
+              <a:tr h="585216">
                 <a:tc>
                   <a:txBody>
                     <a:bodyPr/>
                     <a:lstStyle/>
-                    <a:p/>
+                    <a:p>
+                      <a:r>
+                        <a:rPr lang="en-US" sz="1350" b="0">
+                          <a:solidFill>
+                            <a:srgbClr val="334155"/>
+                          </a:solidFill>
+                          <a:latin typeface="Calibri"/>
+                        </a:rPr>
+                        <a:t>Salt</a:t>
+                      </a:r>
+                    </a:p>
                   </a:txBody>
-                  <a:tcPr/>
+                  <a:tcPr>
+                    <a:solidFill>
+                      <a:srgbClr val="FFFFFF"/>
+                    </a:solidFill>
+                  </a:tcPr>
                 </a:tc>
                 <a:tc>
                   <a:txBody>
                     <a:bodyPr/>
                     <a:lstStyle/>
-                    <a:p/>
+                    <a:p>
+                      <a:r>
+                        <a:rPr lang="en-US" sz="1350" b="0">
+                          <a:solidFill>
+                            <a:srgbClr val="334155"/>
+                          </a:solidFill>
+                          <a:latin typeface="Calibri"/>
+                        </a:rPr>
+                        <a:t>1 3/4 tsp</a:t>
+                      </a:r>
+                    </a:p>
                   </a:txBody>
-                  <a:tcPr/>
+                  <a:tcPr>
+                    <a:solidFill>
+                      <a:srgbClr val="FFFFFF"/>
+                    </a:solidFill>
+                  </a:tcPr>
                 </a:tc>
                 <a:tc>
                   <a:txBody>
                     <a:bodyPr/>
                     <a:lstStyle/>
-                    <a:p/>
+                    <a:p>
+                      <a:r>
+                        <a:rPr lang="en-US" sz="1350" b="0">
+                          <a:solidFill>
+                            <a:srgbClr val="334155"/>
+                          </a:solidFill>
+                          <a:latin typeface="Calibri"/>
+                        </a:rPr>
+                        <a:t>Fine sea salt or kosher salt</a:t>
+                      </a:r>
+                    </a:p>
                   </a:txBody>
-                  <a:tcPr/>
+                  <a:tcPr>
+                    <a:solidFill>
+                      <a:srgbClr val="FFFFFF"/>
+                    </a:solidFill>
+                  </a:tcPr>
+                </a:tc>
+              </a:tr>
+              <a:tr h="585216">
+                <a:tc>
+                  <a:txBody>
+                    <a:bodyPr/>
+                    <a:lstStyle/>
+                    <a:p>
+                      <a:r>
+                        <a:rPr lang="en-US" sz="1350" b="0">
+                          <a:solidFill>
+                            <a:srgbClr val="334155"/>
+                          </a:solidFill>
+                          <a:latin typeface="Calibri"/>
+                        </a:rPr>
+                        <a:t>Active Dry Yeast</a:t>
+                      </a:r>
+                    </a:p>
+                  </a:txBody>
+                  <a:tcPr>
+                    <a:solidFill>
+                      <a:srgbClr val="F8FAFC"/>
+                    </a:solidFill>
+                  </a:tcPr>
+                </a:tc>
+                <a:tc>
+                  <a:txBody>
+                    <a:bodyPr/>
+                    <a:lstStyle/>
+                    <a:p>
+                      <a:r>
+                        <a:rPr lang="en-US" sz="1350" b="0">
+                          <a:solidFill>
+                            <a:srgbClr val="334155"/>
+                          </a:solidFill>
+                          <a:latin typeface="Calibri"/>
+                        </a:rPr>
+                        <a:t>1/2 tsp</a:t>
+                      </a:r>
+                    </a:p>
+                  </a:txBody>
+                  <a:tcPr>
+                    <a:solidFill>
+                      <a:srgbClr val="F8FAFC"/>
+                    </a:solidFill>
+                  </a:tcPr>
+                </a:tc>
+                <a:tc>
+                  <a:txBody>
+                    <a:bodyPr/>
+                    <a:lstStyle/>
+                    <a:p>
+                      <a:r>
+                        <a:rPr lang="en-US" sz="1350" b="0">
+                          <a:solidFill>
+                            <a:srgbClr val="334155"/>
+                          </a:solidFill>
+                          <a:latin typeface="Calibri"/>
+                        </a:rPr>
+                        <a:t>Instant or dry active yeast</a:t>
+                      </a:r>
+                    </a:p>
+                  </a:txBody>
+                  <a:tcPr>
+                    <a:solidFill>
+                      <a:srgbClr val="F8FAFC"/>
+                    </a:solidFill>
+                  </a:tcPr>
+                </a:tc>
+              </a:tr>
+              <a:tr h="585216">
+                <a:tc>
+                  <a:txBody>
+                    <a:bodyPr/>
+                    <a:lstStyle/>
+                    <a:p>
+                      <a:r>
+                        <a:rPr lang="en-US" sz="1350" b="0">
+                          <a:solidFill>
+                            <a:srgbClr val="334155"/>
+                          </a:solidFill>
+                          <a:latin typeface="Calibri"/>
+                        </a:rPr>
+                        <a:t>Water</a:t>
+                      </a:r>
+                    </a:p>
+                  </a:txBody>
+                  <a:tcPr>
+                    <a:solidFill>
+                      <a:srgbClr val="FFFFFF"/>
+                    </a:solidFill>
+                  </a:tcPr>
+                </a:tc>
+                <a:tc>
+                  <a:txBody>
+                    <a:bodyPr/>
+                    <a:lstStyle/>
+                    <a:p>
+                      <a:r>
+                        <a:rPr lang="en-US" sz="1350" b="0">
+                          <a:solidFill>
+                            <a:srgbClr val="334155"/>
+                          </a:solidFill>
+                          <a:latin typeface="Calibri"/>
+                        </a:rPr>
+                        <a:t>1 1/2 cups</a:t>
+                      </a:r>
+                    </a:p>
+                  </a:txBody>
+                  <a:tcPr>
+                    <a:solidFill>
+                      <a:srgbClr val="FFFFFF"/>
+                    </a:solidFill>
+                  </a:tcPr>
+                </a:tc>
+                <a:tc>
+                  <a:txBody>
+                    <a:bodyPr/>
+                    <a:lstStyle/>
+                    <a:p>
+                      <a:r>
+                        <a:rPr lang="en-US" sz="1350" b="0">
+                          <a:solidFill>
+                            <a:srgbClr val="334155"/>
+                          </a:solidFill>
+                          <a:latin typeface="Calibri"/>
+                        </a:rPr>
+                        <a:t>Room temperature (approx. 70°F)</a:t>
+                      </a:r>
+                    </a:p>
+                  </a:txBody>
+                  <a:tcPr>
+                    <a:solidFill>
+                      <a:srgbClr val="FFFFFF"/>
+                    </a:solidFill>
+                  </a:tcPr>
                 </a:tc>
               </a:tr>
             </a:tbl>
@@ -3545,8 +3779,13 @@
           <a:lstStyle/>
           <a:p>
             <a:r>
-              <a:rPr lang="en-US"/>
-              <a:t>Recipe Details</a:t>
+              <a:rPr sz="3000" b="1">
+                <a:solidFill>
+                  <a:srgbClr val="0F172A"/>
+                </a:solidFill>
+                <a:latin typeface="Calibri"/>
+              </a:rPr>
+              <a:t>Step-by-Step Instructions</a:t>
             </a:r>
           </a:p>
         </p:txBody>
@@ -3560,69 +3799,199 @@
           <p:nvPr>
             <p:ph idx="1"/>
           </p:nvPr>
-        </p:nvSpPr>
-        <p:spPr/>
-        <p:txBody>
-          <a:bodyPr/>
-          <a:lstStyle/>
-          <a:p/>
-        </p:txBody>
-      </p:sp>
-      <p:graphicFrame>
-        <p:nvGraphicFramePr>
-          <p:cNvPr id="4" name="Ingredient Proportions Chart"/>
-          <p:cNvGraphicFramePr>
-            <a:graphicFrameLocks noGrp="1"/>
-          </p:cNvGraphicFramePr>
-          <p:nvPr/>
-        </p:nvGraphicFramePr>
-        <p:xfrm>
-          <a:off x="914400" y="1828800"/>
-          <a:ext cx="3657600" cy="2743200"/>
-        </p:xfrm>
-        <a:graphic>
-          <a:graphicData uri="http://schemas.openxmlformats.org/drawingml/2006/chart">
-            <c:chart xmlns:c="http://schemas.openxmlformats.org/drawingml/2006/chart" r:id="rId2"/>
-          </a:graphicData>
-        </a:graphic>
-      </p:graphicFrame>
-      <p:sp>
-        <p:nvSpPr>
-          <p:cNvPr id="5" name="Bread Baking Video"/>
-          <p:cNvSpPr/>
-          <p:nvPr/>
         </p:nvSpPr>
         <p:spPr>
           <a:xfrm>
-            <a:off x="5029200" y="1828800"/>
-            <a:ext cx="3200400" cy="2286000"/>
+            <a:off x="731520" y="1463040"/>
+            <a:ext cx="7680960" cy="4754880"/>
           </a:xfrm>
-          <a:prstGeom prst="rect">
-            <a:avLst/>
-          </a:prstGeom>
+          <a:solidFill>
+            <a:srgbClr val="F8FAFC"/>
+          </a:solidFill>
+          <a:ln w="12700">
+            <a:solidFill>
+              <a:srgbClr val="CBD5E1"/>
+            </a:solidFill>
+          </a:ln>
         </p:spPr>
-        <p:style>
-          <a:lnRef idx="1">
-            <a:schemeClr val="accent1"/>
-          </a:lnRef>
-          <a:fillRef idx="3">
-            <a:schemeClr val="accent1"/>
-          </a:fillRef>
-          <a:effectRef idx="2">
-            <a:schemeClr val="accent1"/>
-          </a:effectRef>
-          <a:fontRef idx="minor">
-            <a:schemeClr val="lt1"/>
-          </a:fontRef>
-        </p:style>
-        <p:txBody>
-          <a:bodyPr rtlCol="0" anchor="ctr"/>
-          <a:lstStyle/>
-          <a:p>
-            <a:pPr algn="ctr"/>
-          </a:p>
-        </p:txBody>
-        <p:videoFile/>
+        <p:txBody>
+          <a:bodyPr lIns="256032" rIns="256032" tIns="256032" bIns="256032" wrap="square"/>
+          <a:lstStyle/>
+          <a:p>
+            <a:pPr marL="342900" indent="-342900">
+              <a:spcBef>
+                <a:spcPts val="0"/>
+              </a:spcBef>
+              <a:spcAft>
+                <a:spcPts val="1000"/>
+              </a:spcAft>
+              <a:buAutoNum type="arabicPeriod"/>
+            </a:pPr>
+            <a:r>
+              <a:rPr sz="1350" b="1">
+                <a:solidFill>
+                  <a:srgbClr val="0F172A"/>
+                </a:solidFill>
+                <a:latin typeface="Calibri"/>
+              </a:rPr>
+              <a:t>Whisk Dry Ingredients — </a:t>
+            </a:r>
+            <a:r>
+              <a:rPr sz="1300" b="0">
+                <a:solidFill>
+                  <a:srgbClr val="334155"/>
+                </a:solidFill>
+                <a:latin typeface="Calibri"/>
+              </a:rPr>
+              <a:t>In a large bowl, whisk together 3 cups all-purpose flour, 1¾ tsp fine salt, and ½ tsp active dry yeast.</a:t>
+            </a:r>
+          </a:p>
+          <a:p>
+            <a:pPr marL="342900" indent="-342900">
+              <a:spcBef>
+                <a:spcPts val="0"/>
+              </a:spcBef>
+              <a:spcAft>
+                <a:spcPts val="1000"/>
+              </a:spcAft>
+              <a:buAutoNum type="arabicPeriod"/>
+            </a:pPr>
+            <a:r>
+              <a:rPr sz="1350" b="1">
+                <a:solidFill>
+                  <a:srgbClr val="0F172A"/>
+                </a:solidFill>
+                <a:latin typeface="Calibri"/>
+              </a:rPr>
+              <a:t>Form Shaggy Dough — </a:t>
+            </a:r>
+            <a:r>
+              <a:rPr sz="1300" b="0">
+                <a:solidFill>
+                  <a:srgbClr val="334155"/>
+                </a:solidFill>
+                <a:latin typeface="Calibri"/>
+              </a:rPr>
+              <a:t>Pour in 1½ cups room-temperature water. Mix with a wooden spoon or spatula until thoroughly incorporated.</a:t>
+            </a:r>
+          </a:p>
+          <a:p>
+            <a:pPr marL="342900" indent="-342900">
+              <a:spcBef>
+                <a:spcPts val="0"/>
+              </a:spcBef>
+              <a:spcAft>
+                <a:spcPts val="1000"/>
+              </a:spcAft>
+              <a:buAutoNum type="arabicPeriod"/>
+            </a:pPr>
+            <a:r>
+              <a:rPr sz="1350" b="1">
+                <a:solidFill>
+                  <a:srgbClr val="0F172A"/>
+                </a:solidFill>
+                <a:latin typeface="Calibri"/>
+              </a:rPr>
+              <a:t>Overnight Counter Ferment — </a:t>
+            </a:r>
+            <a:r>
+              <a:rPr sz="1300" b="0">
+                <a:solidFill>
+                  <a:srgbClr val="334155"/>
+                </a:solidFill>
+                <a:latin typeface="Calibri"/>
+              </a:rPr>
+              <a:t>Cover bowl tightly with plastic wrap. Let rest at room temperature for 12 to 18 hours until bubbly and doubled.</a:t>
+            </a:r>
+          </a:p>
+          <a:p>
+            <a:pPr marL="342900" indent="-342900">
+              <a:spcBef>
+                <a:spcPts val="0"/>
+              </a:spcBef>
+              <a:spcAft>
+                <a:spcPts val="1000"/>
+              </a:spcAft>
+              <a:buAutoNum type="arabicPeriod"/>
+            </a:pPr>
+            <a:r>
+              <a:rPr sz="1350" b="1">
+                <a:solidFill>
+                  <a:srgbClr val="0F172A"/>
+                </a:solidFill>
+                <a:latin typeface="Calibri"/>
+              </a:rPr>
+              <a:t>Preheat Oven &amp; Dutch Oven — </a:t>
+            </a:r>
+            <a:r>
+              <a:rPr sz="1300" b="0">
+                <a:solidFill>
+                  <a:srgbClr val="334155"/>
+                </a:solidFill>
+                <a:latin typeface="Calibri"/>
+              </a:rPr>
+              <a:t>Place covered cast iron Dutch oven inside oven. Preheat both together to 450°F (230°C) for at least 30 minutes.</a:t>
+            </a:r>
+          </a:p>
+          <a:p>
+            <a:pPr marL="342900" indent="-342900">
+              <a:spcBef>
+                <a:spcPts val="0"/>
+              </a:spcBef>
+              <a:spcAft>
+                <a:spcPts val="1000"/>
+              </a:spcAft>
+              <a:buAutoNum type="arabicPeriod"/>
+            </a:pPr>
+            <a:r>
+              <a:rPr sz="1350" b="1">
+                <a:solidFill>
+                  <a:srgbClr val="0F172A"/>
+                </a:solidFill>
+                <a:latin typeface="Calibri"/>
+              </a:rPr>
+              <a:t>Shape &amp; Transfer Dough — </a:t>
+            </a:r>
+            <a:r>
+              <a:rPr sz="1300" b="0">
+                <a:solidFill>
+                  <a:srgbClr val="334155"/>
+                </a:solidFill>
+                <a:latin typeface="Calibri"/>
+              </a:rPr>
+              <a:t>With generously floured hands, turn dough onto a floured counter, shape into a ball, and drop into hot pot.</a:t>
+            </a:r>
+          </a:p>
+          <a:p>
+            <a:pPr marL="342900" indent="-342900">
+              <a:spcBef>
+                <a:spcPts val="0"/>
+              </a:spcBef>
+              <a:spcAft>
+                <a:spcPts val="1000"/>
+              </a:spcAft>
+              <a:buAutoNum type="arabicPeriod"/>
+            </a:pPr>
+            <a:r>
+              <a:rPr sz="1350" b="1">
+                <a:solidFill>
+                  <a:srgbClr val="0F172A"/>
+                </a:solidFill>
+                <a:latin typeface="Calibri"/>
+              </a:rPr>
+              <a:t>Covered &amp; Uncovered Bake — </a:t>
+            </a:r>
+            <a:r>
+              <a:rPr sz="1300" b="0">
+                <a:solidFill>
+                  <a:srgbClr val="334155"/>
+                </a:solidFill>
+                <a:latin typeface="Calibri"/>
+              </a:rPr>
+              <a:t>Bake covered 30 minutes to trap steam. Remove lid and bake 15 to 20 minutes more until crust is deeply golden.</a:t>
+            </a:r>
+          </a:p>
+        </p:txBody>
       </p:sp>
     </p:spTree>
   </p:cSld>
@@ -3644,29 +4013,182 @@
       <p:grpSpPr/>
       <p:sp>
         <p:nvSpPr>
-          <p:cNvPr id="2" name="Floating Text Box"/>
-          <p:cNvSpPr txBox="1"/>
-          <p:nvPr/>
+          <p:cNvPr id="2" name="Title 1"/>
+          <p:cNvSpPr>
+            <a:spLocks noGrp="1"/>
+          </p:cNvSpPr>
+          <p:nvPr>
+            <p:ph type="title"/>
+          </p:nvPr>
+        </p:nvSpPr>
+        <p:spPr/>
+        <p:txBody>
+          <a:bodyPr/>
+          <a:lstStyle/>
+          <a:p>
+            <a:r>
+              <a:rPr sz="3000" b="1">
+                <a:solidFill>
+                  <a:srgbClr val="0F172A"/>
+                </a:solidFill>
+                <a:latin typeface="Calibri"/>
+              </a:rPr>
+              <a:t>Serving &amp; Storage Tips</a:t>
+            </a:r>
+          </a:p>
+        </p:txBody>
+      </p:sp>
+      <p:sp>
+        <p:nvSpPr>
+          <p:cNvPr id="3" name="Content Placeholder 2"/>
+          <p:cNvSpPr>
+            <a:spLocks noGrp="1"/>
+          </p:cNvSpPr>
+          <p:nvPr>
+            <p:ph idx="1"/>
+          </p:nvPr>
         </p:nvSpPr>
         <p:spPr>
           <a:xfrm>
-            <a:off x="914400" y="1371600"/>
-            <a:ext cx="7315200" cy="2743200"/>
+            <a:off x="731520" y="1463040"/>
+            <a:ext cx="7680960" cy="4754880"/>
           </a:xfrm>
-          <a:prstGeom prst="rect">
-            <a:avLst/>
-          </a:prstGeom>
-          <a:noFill/>
+          <a:solidFill>
+            <a:srgbClr val="F8FAFC"/>
+          </a:solidFill>
+          <a:ln w="12700">
+            <a:solidFill>
+              <a:srgbClr val="CBD5E1"/>
+            </a:solidFill>
+          </a:ln>
         </p:spPr>
         <p:txBody>
-          <a:bodyPr wrap="none">
-            <a:spAutoFit/>
-          </a:bodyPr>
-          <a:lstStyle/>
-          <a:p>
-            <a:r>
-              <a:rPr lang="en-US"/>
-              <a:t>Serving Tips: Let bread cool before slicing. This slide uses floating text without semantic layout.</a:t>
+          <a:bodyPr lIns="256032" rIns="256032" tIns="256032" bIns="256032" wrap="square"/>
+          <a:lstStyle/>
+          <a:p>
+            <a:pPr marL="342900" indent="-342900">
+              <a:spcBef>
+                <a:spcPts val="0"/>
+              </a:spcBef>
+              <a:spcAft>
+                <a:spcPts val="1400"/>
+              </a:spcAft>
+              <a:buChar char="•"/>
+            </a:pPr>
+            <a:r>
+              <a:rPr sz="1350" b="1">
+                <a:solidFill>
+                  <a:srgbClr val="0F172A"/>
+                </a:solidFill>
+                <a:latin typeface="Calibri"/>
+              </a:rPr>
+              <a:t>Cool Completely Before Slicing: </a:t>
+            </a:r>
+            <a:r>
+              <a:rPr sz="1300" b="0">
+                <a:solidFill>
+                  <a:srgbClr val="334155"/>
+                </a:solidFill>
+                <a:latin typeface="Calibri"/>
+              </a:rPr>
+              <a:t>Allow loaf to rest on a wire cooling rack for at least 1 full hour. Slicing warm bread compresses steam and creates a gummy, dense crumb.</a:t>
+            </a:r>
+          </a:p>
+          <a:p>
+            <a:pPr marL="342900" indent="-342900">
+              <a:spcBef>
+                <a:spcPts val="0"/>
+              </a:spcBef>
+              <a:spcAft>
+                <a:spcPts val="1400"/>
+              </a:spcAft>
+              <a:buChar char="•"/>
+            </a:pPr>
+            <a:r>
+              <a:rPr sz="1350" b="1">
+                <a:solidFill>
+                  <a:srgbClr val="0F172A"/>
+                </a:solidFill>
+                <a:latin typeface="Calibri"/>
+              </a:rPr>
+              <a:t>Preserve Crust Crispness: </a:t>
+            </a:r>
+            <a:r>
+              <a:rPr sz="1300" b="0">
+                <a:solidFill>
+                  <a:srgbClr val="334155"/>
+                </a:solidFill>
+                <a:latin typeface="Calibri"/>
+              </a:rPr>
+              <a:t>Store cut-side down in a breathable paper bag or wooden bread box at room temperature for up to 3 days. Never store in plastic bags, which soften the crust.</a:t>
+            </a:r>
+          </a:p>
+          <a:p>
+            <a:pPr marL="342900" indent="-342900">
+              <a:spcBef>
+                <a:spcPts val="0"/>
+              </a:spcBef>
+              <a:spcAft>
+                <a:spcPts val="1400"/>
+              </a:spcAft>
+              <a:buChar char="•"/>
+            </a:pPr>
+            <a:r>
+              <a:rPr sz="1350" b="1">
+                <a:solidFill>
+                  <a:srgbClr val="0F172A"/>
+                </a:solidFill>
+                <a:latin typeface="Calibri"/>
+              </a:rPr>
+              <a:t>Artisanal Serving Pairings: </a:t>
+            </a:r>
+            <a:r>
+              <a:rPr sz="1300" b="0">
+                <a:solidFill>
+                  <a:srgbClr val="334155"/>
+                </a:solidFill>
+                <a:latin typeface="Calibri"/>
+              </a:rPr>
+              <a:t>Slice thick and serve warm with salted European cultured butter, extra virgin olive oil with flaky sea salt, artisan cheeses, or alongside hearty soups.</a:t>
+            </a:r>
+          </a:p>
+          <a:p>
+            <a:pPr marL="342900" indent="-342900">
+              <a:spcBef>
+                <a:spcPts val="0"/>
+              </a:spcBef>
+              <a:spcAft>
+                <a:spcPts val="1400"/>
+              </a:spcAft>
+              <a:buChar char="•"/>
+            </a:pPr>
+            <a:r>
+              <a:rPr sz="1350" b="1">
+                <a:solidFill>
+                  <a:srgbClr val="0F172A"/>
+                </a:solidFill>
+                <a:latin typeface="Calibri"/>
+              </a:rPr>
+              <a:t>Baker's Companion Guide: </a:t>
+            </a:r>
+            <a:r>
+              <a:rPr sz="1300" b="0">
+                <a:solidFill>
+                  <a:srgbClr val="334155"/>
+                </a:solidFill>
+                <a:latin typeface="Calibri"/>
+              </a:rPr>
+              <a:t>Looking for crumb analysis, hydration scaling, and Dutch oven troubleshooting? </a:t>
+            </a:r>
+            <a:r>
+              <a:rPr sz="1300" b="1">
+                <a:solidFill>
+                  <a:srgbClr val="0369A1"/>
+                </a:solidFill>
+                <a:latin typeface="Calibri"/>
+                <a:hlinkClick r:id="rId2"/>
+              </a:rPr>
+              <a:t>click here</a:t>
             </a:r>
           </a:p>
         </p:txBody>

</xml_diff>

<commit_message>
feat(examples): insert MS Accessibility Assistant barriers into No Knead Bread-test.pptx and add auto-remediation
</commit_message>
<xml_diff>
--- a/examples/No Knead Bread-test.pptx
+++ b/examples/No Knead Bread-test.pptx
@@ -108,6 +108,7 @@
       </a:defRPr>
     </a:lvl9pPr>
   </p:defaultTextStyle>
+  <p:modifyVerifier cryptProviderType="rsaAES" cryptAlgorithmClass="hash"/>
   <p:extLst>
     <p:ext uri="{521415D9-36F7-43E2-AB2F-EE9909263876}">
       <p14:sectionLst xmlns:p14="http://schemas.microsoft.com/office/powerpoint/2010/main">
@@ -3119,7 +3120,7 @@
             <a:r>
               <a:rPr sz="1800" b="0">
                 <a:solidFill>
-                  <a:srgbClr val="475569"/>
+                  <a:srgbClr val="94A3B8"/>
                 </a:solidFill>
                 <a:latin typeface="Calibri"/>
               </a:rPr>
@@ -3187,17 +3188,7 @@
         <p:txBody>
           <a:bodyPr/>
           <a:lstStyle/>
-          <a:p>
-            <a:r>
-              <a:rPr sz="3000" b="1">
-                <a:solidFill>
-                  <a:srgbClr val="0F172A"/>
-                </a:solidFill>
-                <a:latin typeface="Calibri"/>
-              </a:rPr>
-              <a:t>Introduction &amp; Overview</a:t>
-            </a:r>
-          </a:p>
+          <a:p/>
         </p:txBody>
       </p:sp>
       <p:sp>
@@ -3696,19 +3687,13 @@
                     </a:solidFill>
                   </a:tcPr>
                 </a:tc>
-                <a:tc>
+                <a:tc gridSpan="2">
                   <a:txBody>
                     <a:bodyPr/>
                     <a:lstStyle/>
                     <a:p>
                       <a:r>
-                        <a:rPr lang="en-US" sz="1350" b="0">
-                          <a:solidFill>
-                            <a:srgbClr val="334155"/>
-                          </a:solidFill>
-                          <a:latin typeface="Calibri"/>
-                        </a:rPr>
-                        <a:t>1 1/2 cups</a:t>
+                        <a:t>1 1/2 cups (Room temperature, approx. 70°F)</a:t>
                       </a:r>
                     </a:p>
                   </a:txBody>
@@ -3722,17 +3707,7 @@
                   <a:txBody>
                     <a:bodyPr/>
                     <a:lstStyle/>
-                    <a:p>
-                      <a:r>
-                        <a:rPr lang="en-US" sz="1350" b="0">
-                          <a:solidFill>
-                            <a:srgbClr val="334155"/>
-                          </a:solidFill>
-                          <a:latin typeface="Calibri"/>
-                        </a:rPr>
-                        <a:t>Room temperature (approx. 70°F)</a:t>
-                      </a:r>
-                    </a:p>
+                    <a:p/>
                   </a:txBody>
                   <a:tcPr>
                     <a:solidFill>
@@ -4033,7 +4008,7 @@
                 </a:solidFill>
                 <a:latin typeface="Calibri"/>
               </a:rPr>
-              <a:t>Serving &amp; Storage Tips</a:t>
+              <a:t>Step-by-Step Instructions</a:t>
             </a:r>
           </a:p>
         </p:txBody>

</xml_diff>

<commit_message>
fix(examples): ensure section structure, merged cells, and text contrast conform to MS Accessibility Assistant detection rules
</commit_message>
<xml_diff>
--- a/examples/No Knead Bread-test.pptx
+++ b/examples/No Knead Bread-test.pptx
@@ -109,11 +109,21 @@
     </a:lvl9pPr>
   </p:defaultTextStyle>
   <p:extLst>
-    <p:ext uri="{521415D9-36F7-43E2-AB2F-EE9909263876}">
+    <p:ext uri="{521415D9-36F7-43E2-AB2F-B90AF26B5E84}">
       <p14:sectionLst xmlns:p14="http://schemas.microsoft.com/office/powerpoint/2010/main">
-        <p14:section name="Default Section" id="{default-sec-0}"/>
-        <p14:section name="Default Section" id="{default-sec-1}"/>
-        <p14:section name="Default Section" id="{default-sec-2}"/>
+        <p14:section name="Default Section" id="{11111111-1111-1111-1111-111111111111}">
+          <p14:sldIdLst>
+            <p14:sldId id="256"/>
+            <p14:sldId id="257"/>
+          </p14:sldIdLst>
+        </p14:section>
+        <p14:section name="Default Section" id="{22222222-2222-2222-2222-222222222222}">
+          <p14:sldIdLst>
+            <p14:sldId id="258"/>
+            <p14:sldId id="259"/>
+            <p14:sldId id="260"/>
+          </p14:sldIdLst>
+        </p14:section>
       </p14:sectionLst>
     </p:ext>
   </p:extLst>
@@ -3111,13 +3121,17 @@
             <p:ph type="subTitle" idx="1"/>
           </p:nvPr>
         </p:nvSpPr>
-        <p:spPr/>
-        <p:txBody>
-          <a:bodyPr/>
-          <a:lstStyle/>
-          <a:p>
-            <a:r>
-              <a:rPr sz="1800" b="0">
+        <p:spPr>
+          <a:solidFill>
+            <a:srgbClr val="FFFFFF"/>
+          </a:solidFill>
+        </p:spPr>
+        <p:txBody>
+          <a:bodyPr/>
+          <a:lstStyle/>
+          <a:p>
+            <a:r>
+              <a:rPr sz="1400" b="0">
                 <a:solidFill>
                   <a:srgbClr val="94A3B8"/>
                 </a:solidFill>
@@ -3290,7 +3304,7 @@
             <a:r>
               <a:rPr sz="1350" b="0">
                 <a:solidFill>
-                  <a:srgbClr val="334155"/>
+                  <a:srgbClr val="94A3B8"/>
                 </a:solidFill>
                 <a:latin typeface="Calibri"/>
               </a:rPr>
@@ -3702,7 +3716,7 @@
                     </a:solidFill>
                   </a:tcPr>
                 </a:tc>
-                <a:tc>
+                <a:tc hMerge="1">
                   <a:txBody>
                     <a:bodyPr/>
                     <a:lstStyle/>

</xml_diff>